<commit_message>
Mode demo: meaningful FAIL->PASS via value override (not a label change)
demo_modes.mode_demo now echoes throughput=1200, parses it, and evaluates
'throughput_mbs > 1300' -> FAIL. The prod mode overrides throughput to 1400 ->
same test PASSES. Verified live: plain=FAIL (1200), -m prod=PASS (1400).

- configs/demo_modes.yaml + mode-prod.yaml rewritten; deployed to cluster.
- Deck: "A mode file" slide now shows the test (>1300) + the overlay; L5 demo
  shows the FAIL->PASS flip. Render-verified both fit.
- 05-modes.sh + README L5 updated to the new throughput/FAIL->PASS story.

Co-Authored-By: Claude Opus 4.8 (1M context) <noreply@anthropic.com>
</commit_message>
<xml_diff>
--- a/deck/pavilion-workshop.pptx
+++ b/deck/pavilion-workshop.pptx
@@ -1459,7 +1459,7 @@
           <a:lstStyle/>
           <a:p>
             <a:r>
-              <a:t>Modes = reuse. One test, many contexts.</a:t>
+              <a:t>Modes = reuse. One test, many contexts. Here the same test flips FAIL→PASS purely because the mode overrode a value — no edit to the test itself.</a:t>
             </a:r>
           </a:p>
         </p:txBody>
@@ -1529,7 +1529,7 @@
           <a:lstStyle/>
           <a:p>
             <a:r>
-              <a:t>A mode is tiny — here it overrides one variable. Modes can also swap queues, bump resources, toggle features. No test edits required.</a:t>
+              <a:t>The test evaluates throughput_mbs &gt; 1300. Base value 1200 fails it. The prod mode overrides only that variable to 1400, so the same test now passes — no edit to the test.</a:t>
             </a:r>
           </a:p>
         </p:txBody>
@@ -1599,7 +1599,7 @@
           <a:lstStyle/>
           <a:p>
             <a:r>
-              <a:t>The label result is the proof — a plain run parses 'default', the prod mode merges env_label: production on top. Modes merge onto the fully-resolved test.</a:t>
+              <a:t>The result is the proof: base throughput 1200 fails the &gt; 1300 check; the prod mode overrides the value to 1400 and the identical test now passes. Both ran through PBS (qstat).</a:t>
             </a:r>
           </a:p>
         </p:txBody>
@@ -12037,7 +12037,7 @@
                 </a:solidFill>
                 <a:latin typeface="Arial"/>
               </a:rPr>
-              <a:t>•  Our demo: a `prod` mode overrides a variable (env_label: default → production).</a:t>
+              <a:t>•  Our demo: the test fails at throughput 1200; a `prod` mode raises it to 1400 → it passes.</a:t>
             </a:r>
           </a:p>
         </p:txBody>
@@ -12123,7 +12123,7 @@
                 </a:solidFill>
                 <a:latin typeface="Arial"/>
               </a:rPr>
-              <a:t>A mode file</a:t>
+              <a:t>The test, and a mode that changes its outcome</a:t>
             </a:r>
           </a:p>
         </p:txBody>
@@ -12200,7 +12200,7 @@
                 </a:solidFill>
                 <a:latin typeface="Arial"/>
               </a:rPr>
-              <a:t>prod.yaml — just the config keys you want merged on top of a resolved test.</a:t>
+              <a:t>The test measures throughput and requires &gt; 1300. Base is 1200 (FAIL); the mode raises it.</a:t>
             </a:r>
           </a:p>
         </p:txBody>
@@ -12214,7 +12214,7 @@
         <p:spPr>
           <a:xfrm>
             <a:off x="640080" y="2148840"/>
-            <a:ext cx="10972800" cy="4206240"/>
+            <a:ext cx="10972800" cy="4846320"/>
           </a:xfrm>
           <a:prstGeom prst="rect">
             <a:avLst/>
@@ -12248,31 +12248,187 @@
           <a:p>
             <a:pPr algn="l"/>
             <a:r>
-              <a:rPr sz="1400" b="0">
+              <a:rPr sz="1300" b="0">
                 <a:solidFill>
                   <a:srgbClr val="5B6674"/>
                 </a:solidFill>
                 <a:latin typeface="Consolas"/>
               </a:rPr>
-              <a:t># config/modes/prod.yaml</a:t>
-            </a:r>
-          </a:p>
-          <a:p>
-            <a:pPr algn="l"/>
-            <a:r>
-              <a:rPr sz="1400" b="0">
+              <a:t># config/suites/demo_modes.yaml   (the test)</a:t>
+            </a:r>
+          </a:p>
+          <a:p>
+            <a:pPr algn="l"/>
+            <a:r>
+              <a:rPr sz="1300" b="0">
+                <a:solidFill>
+                  <a:srgbClr val="1B2B34"/>
+                </a:solidFill>
+                <a:latin typeface="Consolas"/>
+              </a:rPr>
+              <a:t>mode_demo:</a:t>
+            </a:r>
+          </a:p>
+          <a:p>
+            <a:pPr algn="l"/>
+            <a:r>
+              <a:rPr sz="1300" b="0">
+                <a:solidFill>
+                  <a:srgbClr val="1B2B34"/>
+                </a:solidFill>
+                <a:latin typeface="Consolas"/>
+              </a:rPr>
+              <a:t>  variables:</a:t>
+            </a:r>
+          </a:p>
+          <a:p>
+            <a:pPr algn="l"/>
+            <a:r>
+              <a:rPr sz="1300" b="0">
+                <a:solidFill>
+                  <a:srgbClr val="1B2B34"/>
+                </a:solidFill>
+                <a:latin typeface="Consolas"/>
+              </a:rPr>
+              <a:t>    throughput: 1200</a:t>
+            </a:r>
+          </a:p>
+          <a:p>
+            <a:pPr algn="l"/>
+            <a:r>
+              <a:rPr sz="1300" b="0">
+                <a:solidFill>
+                  <a:srgbClr val="1B2B34"/>
+                </a:solidFill>
+                <a:latin typeface="Consolas"/>
+              </a:rPr>
+              <a:t>  run:</a:t>
+            </a:r>
+          </a:p>
+          <a:p>
+            <a:pPr algn="l"/>
+            <a:r>
+              <a:rPr sz="1300" b="0">
+                <a:solidFill>
+                  <a:srgbClr val="1B2B34"/>
+                </a:solidFill>
+                <a:latin typeface="Consolas"/>
+              </a:rPr>
+              <a:t>    cmds:</a:t>
+            </a:r>
+          </a:p>
+          <a:p>
+            <a:pPr algn="l"/>
+            <a:r>
+              <a:rPr sz="1300" b="0">
+                <a:solidFill>
+                  <a:srgbClr val="1B2B34"/>
+                </a:solidFill>
+                <a:latin typeface="Consolas"/>
+              </a:rPr>
+              <a:t>      - 'echo "throughput {{throughput}}"'</a:t>
+            </a:r>
+          </a:p>
+          <a:p>
+            <a:pPr algn="l"/>
+            <a:r>
+              <a:rPr sz="1300" b="0">
+                <a:solidFill>
+                  <a:srgbClr val="1B2B34"/>
+                </a:solidFill>
+                <a:latin typeface="Consolas"/>
+              </a:rPr>
+              <a:t>  result_parse:</a:t>
+            </a:r>
+          </a:p>
+          <a:p>
+            <a:pPr algn="l"/>
+            <a:r>
+              <a:rPr sz="1300" b="0">
+                <a:solidFill>
+                  <a:srgbClr val="1B2B34"/>
+                </a:solidFill>
+                <a:latin typeface="Consolas"/>
+              </a:rPr>
+              <a:t>    regex:</a:t>
+            </a:r>
+          </a:p>
+          <a:p>
+            <a:pPr algn="l"/>
+            <a:r>
+              <a:rPr sz="1300" b="0">
+                <a:solidFill>
+                  <a:srgbClr val="1B2B34"/>
+                </a:solidFill>
+                <a:latin typeface="Consolas"/>
+              </a:rPr>
+              <a:t>      throughput_mbs:</a:t>
+            </a:r>
+          </a:p>
+          <a:p>
+            <a:pPr algn="l"/>
+            <a:r>
+              <a:rPr sz="1300" b="0">
+                <a:solidFill>
+                  <a:srgbClr val="1B2B34"/>
+                </a:solidFill>
+                <a:latin typeface="Consolas"/>
+              </a:rPr>
+              <a:t>        regex: 'throughput (\S+)'</a:t>
+            </a:r>
+          </a:p>
+          <a:p>
+            <a:pPr algn="l"/>
+            <a:r>
+              <a:rPr sz="1300" b="0">
+                <a:solidFill>
+                  <a:srgbClr val="1B2B34"/>
+                </a:solidFill>
+                <a:latin typeface="Consolas"/>
+              </a:rPr>
+              <a:t>  result_evaluate:</a:t>
+            </a:r>
+          </a:p>
+          <a:p>
+            <a:pPr algn="l"/>
+            <a:r>
+              <a:rPr sz="1300" b="0">
+                <a:solidFill>
+                  <a:srgbClr val="1B2B34"/>
+                </a:solidFill>
+                <a:latin typeface="Consolas"/>
+              </a:rPr>
+              <a:t>    result: 'throughput_mbs &gt; 1300'      # PASS only if above 1300</a:t>
+            </a:r>
+          </a:p>
+          <a:p>
+            <a:pPr algn="l"/>
+            <a:r>
+              <a:rPr sz="1300" b="0">
+                <a:solidFill>
+                  <a:srgbClr val="1B2B34"/>
+                </a:solidFill>
+                <a:latin typeface="Consolas"/>
+              </a:rPr>
+              <a:t> </a:t>
+            </a:r>
+          </a:p>
+          <a:p>
+            <a:pPr algn="l"/>
+            <a:r>
+              <a:rPr sz="1300" b="0">
                 <a:solidFill>
                   <a:srgbClr val="5B6674"/>
                 </a:solidFill>
                 <a:latin typeface="Consolas"/>
               </a:rPr>
-              <a:t># Apply with:  pav run -m prod &lt;test&gt;</a:t>
-            </a:r>
-          </a:p>
-          <a:p>
-            <a:pPr algn="l"/>
-            <a:r>
-              <a:rPr sz="1400" b="0">
+              <a:t># config/modes/prod.yaml   (the mode overlay)</a:t>
+            </a:r>
+          </a:p>
+          <a:p>
+            <a:pPr algn="l"/>
+            <a:r>
+              <a:rPr sz="1300" b="0">
                 <a:solidFill>
                   <a:srgbClr val="1B2B34"/>
                 </a:solidFill>
@@ -12284,13 +12440,13 @@
           <a:p>
             <a:pPr algn="l"/>
             <a:r>
-              <a:rPr sz="1400" b="0">
-                <a:solidFill>
-                  <a:srgbClr val="1B2B34"/>
-                </a:solidFill>
-                <a:latin typeface="Consolas"/>
-              </a:rPr>
-              <a:t>  env_label: 'production'</a:t>
+              <a:rPr sz="1300" b="0">
+                <a:solidFill>
+                  <a:srgbClr val="1B2B34"/>
+                </a:solidFill>
+                <a:latin typeface="Consolas"/>
+              </a:rPr>
+              <a:t>  throughput: 1400                        # override 1200 -&gt; 1400</a:t>
             </a:r>
           </a:p>
         </p:txBody>
@@ -12624,7 +12780,7 @@
                 </a:solidFill>
                 <a:latin typeface="Arial"/>
               </a:rPr>
-              <a:t>A mode overrides config</a:t>
+              <a:t>A mode flips FAIL → PASS</a:t>
             </a:r>
           </a:p>
         </p:txBody>
@@ -12773,7 +12929,7 @@
                 </a:solidFill>
                 <a:latin typeface="Consolas"/>
               </a:rPr>
-              <a:t>$ pav run -m prod demo_modes.mode_demo    # apply the prod overlay</a:t>
+              <a:t>$ pav run demo_modes.mode_demo           # base: throughput = 1200</a:t>
             </a:r>
           </a:p>
           <a:p>
@@ -12785,7 +12941,7 @@
                 </a:solidFill>
                 <a:latin typeface="Consolas"/>
               </a:rPr>
-              <a:t>sid: s73</a:t>
+              <a:t>  'throughput_mbs': 1200,</a:t>
             </a:r>
           </a:p>
           <a:p>
@@ -12793,11 +12949,11 @@
             <a:r>
               <a:rPr sz="1250" b="0">
                 <a:solidFill>
-                  <a:srgbClr val="1B2B34"/>
-                </a:solidFill>
-                <a:latin typeface="Consolas"/>
-              </a:rPr>
-              <a:t>tests: 1</a:t>
+                  <a:srgbClr val="B32A2A"/>
+                </a:solidFill>
+                <a:latin typeface="Consolas"/>
+              </a:rPr>
+              <a:t>  'result': 'FAIL'          # 1200 &gt; 1300 is false</a:t>
             </a:r>
           </a:p>
           <a:p>
@@ -12821,7 +12977,7 @@
                 </a:solidFill>
                 <a:latin typeface="Consolas"/>
               </a:rPr>
-              <a:t>$ qstat -a                                # dispatched to PBS</a:t>
+              <a:t>$ qstat -a                                # a real PBS job</a:t>
             </a:r>
           </a:p>
           <a:p>
@@ -12833,7 +12989,7 @@
                 </a:solidFill>
                 <a:latin typeface="Consolas"/>
               </a:rPr>
-              <a:t>8386.pbs-server pavilion workq pav_demo_*  1  1  R</a:t>
+              <a:t>8407.pbs-server pavilion workq pav_demo_*  1  1  R</a:t>
             </a:r>
           </a:p>
           <a:p>
@@ -12857,7 +13013,7 @@
                 </a:solidFill>
                 <a:latin typeface="Consolas"/>
               </a:rPr>
-              <a:t>$ pav results --full s73</a:t>
+              <a:t>$ pav run -m prod demo_modes.mode_demo    # prod overrides -&gt; throughput = 1400</a:t>
             </a:r>
           </a:p>
           <a:p>
@@ -12869,7 +13025,7 @@
                 </a:solidFill>
                 <a:latin typeface="Consolas"/>
               </a:rPr>
-              <a:t>  'name': 'demo_modes.mode_demo',</a:t>
+              <a:t>  'throughput_mbs': 1400,</a:t>
             </a:r>
           </a:p>
           <a:p>
@@ -12877,23 +13033,11 @@
             <a:r>
               <a:rPr sz="1250" b="0">
                 <a:solidFill>
-                  <a:srgbClr val="1B2B34"/>
-                </a:solidFill>
-                <a:latin typeface="Consolas"/>
-              </a:rPr>
-              <a:t>  'label': 'production',</a:t>
-            </a:r>
-          </a:p>
-          <a:p>
-            <a:pPr algn="l"/>
-            <a:r>
-              <a:rPr sz="1250" b="0">
-                <a:solidFill>
-                  <a:srgbClr val="1B2B34"/>
-                </a:solidFill>
-                <a:latin typeface="Consolas"/>
-              </a:rPr>
-              <a:t>  'var': {'env_label': 'production'}</a:t>
+                  <a:srgbClr val="1E7D3C"/>
+                </a:solidFill>
+                <a:latin typeface="Consolas"/>
+              </a:rPr>
+              <a:t>  'result': 'PASS'          # 1400 &gt; 1300 is true</a:t>
             </a:r>
           </a:p>
         </p:txBody>
@@ -12927,7 +13071,7 @@
                 </a:solidFill>
                 <a:latin typeface="Arial"/>
               </a:rPr>
-              <a:t>Plain, env_label is 'default'; with `-m prod` the overlay flips it to 'production'.</a:t>
+              <a:t>Same test, no edits — the prod mode raised throughput past the 1300 threshold, flipping FAIL → PASS.</a:t>
             </a:r>
           </a:p>
         </p:txBody>

</xml_diff>

<commit_message>
saLog demo actually writes a fresh row now (per_file test + plugin fix)
- Added demo_pbs.salog: redirects to $(hostname).log and parses it with
  per_file: name, so the sa_log logger has per-node data to record.
- 12-salog.sh now runs demo_pbs.salog (cd's to ~/pavilion2 so saLog's relative
  salog_output.txt lands where tail reads it). README saLog row updated.
- Deck saLog slide shows the single-test flow + the real fresh CSV row.
- Pairs with the sa_log plugin fix in the result_loggers repo (reads 'file').
  Verified live: a new row is appended on each run.

Co-Authored-By: Claude Opus 4.8 (1M context) <noreply@anthropic.com>
</commit_message>
<xml_diff>
--- a/deck/pavilion-workshop.pptx
+++ b/deck/pavilion-workshop.pptx
@@ -2299,7 +2299,7 @@
           <a:lstStyle/>
           <a:p>
             <a:r>
-              <a:t>saLog is a logger specific to us (NASA/NOAA). Pavilion's sa_log result plugin invokes it as nodes are released from the PBS job — one CSV row per node, with the test result. It writes node(s), content (result), user, and the 'released' action.</a:t>
+              <a:t>saLog is a logger specific to us (NASA/NOAA). The test uses a per_file: name parser so each node's result is recorded; Pavilion's sa_log plugin then invokes saLog once per node with the 'released' action, writing node, content (result), user, action to the CSV.</a:t>
             </a:r>
           </a:p>
         </p:txBody>
@@ -16473,7 +16473,7 @@
                 </a:solidFill>
                 <a:latin typeface="Consolas"/>
               </a:rPr>
-              <a:t>$ pav run demo_pbs.pass demo_pbs.fail    # 1. run in Pavilion</a:t>
+              <a:t>$ pav run demo_pbs.salog                 # 1. run in Pavilion (per_file: name)</a:t>
             </a:r>
           </a:p>
           <a:p>
@@ -16485,7 +16485,7 @@
                 </a:solidFill>
                 <a:latin typeface="Consolas"/>
               </a:rPr>
-              <a:t>sid: s70</a:t>
+              <a:t>sid: s141</a:t>
             </a:r>
           </a:p>
           <a:p>
@@ -16497,7 +16497,7 @@
                 </a:solidFill>
                 <a:latin typeface="Consolas"/>
               </a:rPr>
-              <a:t>tests: 2</a:t>
+              <a:t>tests: 1</a:t>
             </a:r>
           </a:p>
           <a:p>
@@ -16521,7 +16521,7 @@
                 </a:solidFill>
                 <a:latin typeface="Consolas"/>
               </a:rPr>
-              <a:t>$ qstat -a                               # 2. the jobs, running in PBS</a:t>
+              <a:t>$ qstat -a                               # 2. the job, running in PBS</a:t>
             </a:r>
           </a:p>
           <a:p>
@@ -16533,7 +16533,7 @@
                 </a:solidFill>
                 <a:latin typeface="Consolas"/>
               </a:rPr>
-              <a:t>8383.pbs-server pavilion workq pav_demo_*  1  1  R</a:t>
+              <a:t>8410.pbs-server pavilion workq pav_demo_*  1  1  R</a:t>
             </a:r>
           </a:p>
           <a:p>
@@ -16557,7 +16557,7 @@
                 </a:solidFill>
                 <a:latin typeface="Consolas"/>
               </a:rPr>
-              <a:t>$ tail salog_output.txt                  # 3. the CSV saLog wrote on release</a:t>
+              <a:t>$ tail salog_output.txt                  # 3. the CSV the sa_log plugin wrote on release</a:t>
             </a:r>
           </a:p>
           <a:p>
@@ -16569,19 +16569,7 @@
                 </a:solidFill>
                 <a:latin typeface="Consolas"/>
               </a:rPr>
-              <a:t>x1003c7s7b0n3,"pav_test result=PASS",pavilion,released</a:t>
-            </a:r>
-          </a:p>
-          <a:p>
-            <a:pPr algn="l"/>
-            <a:r>
-              <a:rPr sz="1250" b="0">
-                <a:solidFill>
-                  <a:srgbClr val="B32A2A"/>
-                </a:solidFill>
-                <a:latin typeface="Consolas"/>
-              </a:rPr>
-              <a:t>x1003c7s7b0n1,x1003c7s7b0n2,x1003c7s7b0n3,"pav_test result=FAIL",pavilion,released</a:t>
+              <a:t>x1002c6s2b0n1,"demo_pbs.salog result=PASS",pavilion,released</a:t>
             </a:r>
           </a:p>
         </p:txBody>
@@ -16615,7 +16603,7 @@
                 </a:solidFill>
                 <a:latin typeface="Arial"/>
               </a:rPr>
-              <a:t>Run in Pavilion → jobs in PBS → saLog writes a CSV row as each node is released.</a:t>
+              <a:t>Run in Pavilion → job in PBS → the sa_log plugin calls saLog per node as it's released.</a:t>
             </a:r>
           </a:p>
         </p:txBody>

</xml_diff>

<commit_message>
Series demo: one 'smoke' set runs pass + fail + metrics (drop 'perf')
demo_series.yaml now has a single smoke set running demo_pbs.pass, .fail, and
.metrics. Verified live: 3 tests, 2 PASS + 1 (intentional) FAIL, dispatched
across 2 PBS jobs. Updated the series-file and L6 slides, 06-series.sh, README.

Co-Authored-By: Claude Opus 4.8 (1M context) <noreply@anthropic.com>
</commit_message>
<xml_diff>
--- a/deck/pavilion-workshop.pptx
+++ b/deck/pavilion-workshop.pptx
@@ -1740,7 +1740,7 @@
           <a:lstStyle/>
           <a:p>
             <a:r>
-              <a:t>Sets can be ordered or not; unordered runs them concurrently (robust for a live demo). Each set becomes its own PBS job.</a:t>
+              <a:t>Sets can be ordered or not; unordered runs them concurrently (robust for a live demo). One 'pav series run' launches every test in the set.</a:t>
             </a:r>
           </a:p>
         </p:txBody>
@@ -1810,7 +1810,7 @@
           <a:lstStyle/>
           <a:p>
             <a:r>
-              <a:t>Series group test sets; each set here dispatches its own PBS job (qstat shows two). I use unordered for a robust live run.</a:t>
+              <a:t>Series group tests into sets and run them with one command. The smoke set here holds demo_pbs.pass, .fail, and .metrics — 2 pass, 1 intentional fail. I use unordered for a robust live run.</a:t>
             </a:r>
           </a:p>
         </p:txBody>
@@ -13812,7 +13812,7 @@
                 </a:solidFill>
                 <a:latin typeface="Arial"/>
               </a:rPr>
-              <a:t>demo_series.yaml — name a few test sets; each set lists the tests it runs.</a:t>
+              <a:t>demo_series.yaml — name a test set, list the tests it runs.</a:t>
             </a:r>
           </a:p>
         </p:txBody>
@@ -13938,19 +13938,7 @@
                 </a:solidFill>
                 <a:latin typeface="Consolas"/>
               </a:rPr>
-              <a:t>  perf:</a:t>
-            </a:r>
-          </a:p>
-          <a:p>
-            <a:pPr algn="l"/>
-            <a:r>
-              <a:rPr sz="1400" b="0">
-                <a:solidFill>
-                  <a:srgbClr val="1B2B34"/>
-                </a:solidFill>
-                <a:latin typeface="Consolas"/>
-              </a:rPr>
-              <a:t>    tests:</a:t>
+              <a:t>      - demo_pbs.fail</a:t>
             </a:r>
           </a:p>
           <a:p>
@@ -14221,7 +14209,7 @@
                 </a:solidFill>
                 <a:latin typeface="Consolas"/>
               </a:rPr>
-              <a:t>Started series s74.</a:t>
+              <a:t>Started series s152.</a:t>
             </a:r>
           </a:p>
           <a:p>
@@ -14245,7 +14233,7 @@
                 </a:solidFill>
                 <a:latin typeface="Consolas"/>
               </a:rPr>
-              <a:t>$ qstat -a                        # one PBS job per test set</a:t>
+              <a:t>$ qstat -a                        # the set's tests dispatched to PBS</a:t>
             </a:r>
           </a:p>
           <a:p>
@@ -14257,7 +14245,7 @@
                 </a:solidFill>
                 <a:latin typeface="Consolas"/>
               </a:rPr>
-              <a:t>8387.pbs-server pavilion workq pav_demo_*  1  1  R</a:t>
+              <a:t>9076.pbs-server pavilion workq pav_demo_*  1  1  R</a:t>
             </a:r>
           </a:p>
           <a:p>
@@ -14269,7 +14257,7 @@
                 </a:solidFill>
                 <a:latin typeface="Consolas"/>
               </a:rPr>
-              <a:t>8388.pbs-server pavilion workq pav_demo_*  1  1  R</a:t>
+              <a:t>9077.pbs-server pavilion workq pav_demo_*  1  1  R</a:t>
             </a:r>
           </a:p>
           <a:p>
@@ -14293,7 +14281,7 @@
                 </a:solidFill>
                 <a:latin typeface="Consolas"/>
               </a:rPr>
-              <a:t>$ pav series status s74</a:t>
+              <a:t>$ pav series status s152</a:t>
             </a:r>
           </a:p>
           <a:p>
@@ -14305,7 +14293,7 @@
                 </a:solidFill>
                 <a:latin typeface="Consolas"/>
               </a:rPr>
-              <a:t>Id  | Name        | Status   | Tests | Pass | Fail</a:t>
+              <a:t>Id   | Name        | Status   | Tests | Pass | Fail</a:t>
             </a:r>
           </a:p>
           <a:p>
@@ -14317,7 +14305,7 @@
                 </a:solidFill>
                 <a:latin typeface="Consolas"/>
               </a:rPr>
-              <a:t>s74 | demo_series | COMPLETE |   2   |   2  |   0</a:t>
+              <a:t>s152 | demo_series | COMPLETE |   3   |   2  |   1</a:t>
             </a:r>
           </a:p>
         </p:txBody>
@@ -14351,7 +14339,7 @@
                 </a:solidFill>
                 <a:latin typeface="Arial"/>
               </a:rPr>
-              <a:t>One command runs both test sets as a named series — two PBS jobs, all PASS.</a:t>
+              <a:t>One command runs all three tests in the 'smoke' set — 2 PASS, 1 (intentional) FAIL.</a:t>
             </a:r>
           </a:p>
         </p:txBody>

</xml_diff>

<commit_message>
Renumber demo scripts: inheritance=01, basic=02 … salog=14 (no 00/2b)
Renamed all 14 scripts to a clean 01…14 sequence with inheritance first and a
real 04-evaluate (was 02b). Updated every deck run-cue chip and the README
ladder. Redeployed to ~/pav_demo (old names removed). Scripts are independent —
run them in any order. Also fixed two stale README notes (series is now one
smoke set; the CSV-fallback reference).

Co-Authored-By: Claude Opus 4.8 (1M context) <noreply@anthropic.com>
</commit_message>
<xml_diff>
--- a/deck/pavilion-workshop.pptx
+++ b/deck/pavilion-workshop.pptx
@@ -8072,7 +8072,7 @@
                 </a:solidFill>
                 <a:latin typeface="Arial"/>
               </a:rPr>
-              <a:t>▶  00-inheritance.sh</a:t>
+              <a:t>▶  01-inheritance.sh</a:t>
             </a:r>
           </a:p>
         </p:txBody>
@@ -8721,7 +8721,7 @@
                 </a:solidFill>
                 <a:latin typeface="Arial"/>
               </a:rPr>
-              <a:t>▶  11-history.sh</a:t>
+              <a:t>▶  13-history.sh</a:t>
             </a:r>
           </a:p>
         </p:txBody>
@@ -9134,7 +9134,7 @@
                 </a:solidFill>
                 <a:latin typeface="Arial"/>
               </a:rPr>
-              <a:t>▶  01-basic.sh</a:t>
+              <a:t>▶  02-basic.sh</a:t>
             </a:r>
           </a:p>
         </p:txBody>
@@ -10084,7 +10084,7 @@
                 </a:solidFill>
                 <a:latin typeface="Arial"/>
               </a:rPr>
-              <a:t>▶  02-metrics.sh</a:t>
+              <a:t>▶  03-metrics.sh</a:t>
             </a:r>
           </a:p>
         </p:txBody>
@@ -10928,7 +10928,7 @@
                 </a:solidFill>
                 <a:latin typeface="Arial"/>
               </a:rPr>
-              <a:t>▶  02b-evaluate.sh</a:t>
+              <a:t>▶  04-evaluate.sh</a:t>
             </a:r>
           </a:p>
         </p:txBody>
@@ -11808,7 +11808,7 @@
                 </a:solidFill>
                 <a:latin typeface="Arial"/>
               </a:rPr>
-              <a:t>▶  03-permutations.sh</a:t>
+              <a:t>▶  05-permutations.sh</a:t>
             </a:r>
           </a:p>
         </p:txBody>
@@ -13178,7 +13178,7 @@
                 </a:solidFill>
                 <a:latin typeface="Arial"/>
               </a:rPr>
-              <a:t>▶  04-pbs.sh</a:t>
+              <a:t>▶  06-pbs.sh</a:t>
             </a:r>
           </a:p>
         </p:txBody>
@@ -14310,7 +14310,7 @@
                 </a:solidFill>
                 <a:latin typeface="Arial"/>
               </a:rPr>
-              <a:t>▶  05-modes.sh</a:t>
+              <a:t>▶  07-modes.sh</a:t>
             </a:r>
           </a:p>
         </p:txBody>
@@ -15094,7 +15094,7 @@
                 </a:solidFill>
                 <a:latin typeface="Arial"/>
               </a:rPr>
-              <a:t>▶  06-series.sh</a:t>
+              <a:t>▶  08-series.sh</a:t>
             </a:r>
           </a:p>
         </p:txBody>
@@ -16764,7 +16764,7 @@
                 </a:solidFill>
                 <a:latin typeface="Arial"/>
               </a:rPr>
-              <a:t>▶  07-command-plugins.sh</a:t>
+              <a:t>▶  09-command-plugins.sh</a:t>
             </a:r>
           </a:p>
         </p:txBody>
@@ -17453,7 +17453,7 @@
                 </a:solidFill>
                 <a:latin typeface="Arial"/>
               </a:rPr>
-              <a:t>▶  08-output-csv.sh</a:t>
+              <a:t>▶  10-output-csv.sh</a:t>
             </a:r>
           </a:p>
         </p:txBody>
@@ -17842,7 +17842,7 @@
                 </a:solidFill>
                 <a:latin typeface="Arial"/>
               </a:rPr>
-              <a:t>▶  12-salog.sh</a:t>
+              <a:t>▶  14-salog.sh</a:t>
             </a:r>
           </a:p>
         </p:txBody>
@@ -18207,7 +18207,7 @@
                 </a:solidFill>
                 <a:latin typeface="Arial"/>
               </a:rPr>
-              <a:t>▶  09-opensearch.sh</a:t>
+              <a:t>▶  11-opensearch.sh</a:t>
             </a:r>
           </a:p>
         </p:txBody>
@@ -18620,7 +18620,7 @@
                 </a:solidFill>
                 <a:latin typeface="Arial"/>
               </a:rPr>
-              <a:t>▶  10-mysql.sh</a:t>
+              <a:t>▶  12-mysql.sh</a:t>
             </a:r>
           </a:p>
         </p:txBody>

</xml_diff>